<commit_message>
Post-audit improvements: anaphora fix on by default, learned controller option, CPU thread fix, local LLM client; refresh docs and Docker
</commit_message>
<xml_diff>
--- a/SRMIST_VirtualVanguards_Submission.pptx
+++ b/SRMIST_VirtualVanguards_Submission.pptx
@@ -11247,7 +11247,7 @@
             </a:r>
             <a:r>
               <a:rPr lang="en-US" sz="1400" b="1" dirty="0"/>
-              <a:t>359 tests</a:t>
+              <a:t>373 tests</a:t>
             </a:r>
             <a:endParaRPr lang="en-US" sz="1400" dirty="0"/>
           </a:p>
@@ -14109,7 +14109,7 @@
                           <a:latin typeface="Times New Roman" panose="02020603050405020304" pitchFamily="18" charset="0"/>
                           <a:cs typeface="Times New Roman" panose="02020603050405020304" pitchFamily="18" charset="0"/>
                         </a:rPr>
-                        <a:t>65.7%</a:t>
+                        <a:t>66.7%</a:t>
                       </a:r>
                       <a:r>
                         <a:rPr lang="en-IN" sz="1200">

</xml_diff>